<commit_message>
fix(hlm): step-up reestimado com todos os degraus convergidos
Reexecução completa com um degrau por processo: os sete modelos fecham com
converged=True, incluindo o M3, que antes parava no bfgs. O M3 passa a ser o
ótimo de maior verossimilhança (−7.678.225 contra −7.678.368).

O que muda no relatório é o que a componente de variância indicava: ICC do M3 de
0,161 para 0,144 e variância entre bairros explicada de 75,9% para 78,9%. O
argumento não se move — gap líquido de 10,2%, mediação de 47,0% pelo bairro e
6,99% dentro da mesma ocupação, com β negro variando 0,03%.

Propagado para PDF (38 páginas, 0 erros), Word, guia de defesa, deck da banca,
deck executivo e resultados preliminares — todos leem dos mesmos csv.
Verificador: 0 ALTO, 0 MÉDIO, 0 BAIXO; restam os 2 INFO documentados (bad
controls da Oaxaca-Blinder e estimativas não ponderadas).

Co-Authored-By: Claude Opus 5 (1M context) <noreply@anthropic.com>
</commit_message>
<xml_diff>
--- a/entregaveis/apresentacao_tcc.pptx
+++ b/entregaveis/apresentacao_tcc.pptx
@@ -20933,7 +20933,7 @@
         <p:spPr>
           <a:xfrm>
             <a:off x="1828800" y="3429000"/>
-            <a:ext cx="4369234" cy="731520"/>
+            <a:ext cx="4368183" cy="731520"/>
           </a:xfrm>
           <a:prstGeom prst="rect">
             <a:avLst/>
@@ -20973,7 +20973,7 @@
         </p:nvSpPr>
         <p:spPr>
           <a:xfrm>
-            <a:off x="6307762" y="3611880"/>
+            <a:off x="6306711" y="3611880"/>
             <a:ext cx="914400" cy="411480"/>
           </a:xfrm>
           <a:prstGeom prst="rect">
@@ -21044,7 +21044,7 @@
         </p:nvSpPr>
         <p:spPr>
           <a:xfrm>
-            <a:off x="7249594" y="3538728"/>
+            <a:off x="7248543" y="3538728"/>
             <a:ext cx="4206240" cy="566928"/>
           </a:xfrm>
           <a:prstGeom prst="rect">

</xml_diff>